<commit_message>
Resync slides with current course docs
</commit_message>
<xml_diff>
--- a/slides/deep-learning-project-domains.pptx
+++ b/slides/deep-learning-project-domains.pptx
@@ -5094,7 +5094,7 @@
             </a:pPr>
             <a:r>
               <a:rPr/>
-              <a:t>Deep Learning 2026: Project Paths, Frameworks, and Domains</a:t>
+              <a:t>Deep Learning 2026: Technical Paths and Application Domains</a:t>
             </a:r>
           </a:p>
         </p:txBody>
@@ -5828,7 +5828,14 @@
             <a:pPr lvl="0"/>
             <a:r>
               <a:rPr/>
-              <a:t>This is more than prompting, but less than training from scratch.</a:t>
+              <a:t>Choose this path if you want to adapt a large pretrained model to your own task or style.</a:t>
+            </a:r>
+          </a:p>
+          <a:p>
+            <a:pPr lvl="0"/>
+            <a:r>
+              <a:rPr/>
+              <a:t>This is more than prompting, but less than full retraining.</a:t>
             </a:r>
           </a:p>
           <a:p>
@@ -5952,7 +5959,7 @@
             <a:pPr lvl="0"/>
             <a:r>
               <a:rPr/>
-              <a:t>This path is powerful, but more ambitious than simple inference.</a:t>
+              <a:t>This path is powerful if you want to go beyond simple inference.</a:t>
             </a:r>
           </a:p>
         </p:txBody>
@@ -7522,7 +7529,7 @@
             <a:pPr lvl="1"/>
             <a:r>
               <a:rPr/>
-              <a:t>choose a framework stack</a:t>
+              <a:t>choose an application domain</a:t>
             </a:r>
           </a:p>
           <a:p>
@@ -8746,13 +8753,6 @@
               <a:t>Edge deployment can apply to many domains.</a:t>
             </a:r>
           </a:p>
-          <a:p>
-            <a:pPr lvl="0"/>
-            <a:r>
-              <a:rPr/>
-              <a:t>Generative behavior can appear in text, image, audio, or multimodal systems.</a:t>
-            </a:r>
-          </a:p>
         </p:txBody>
       </p:sp>
     </p:spTree>
@@ -9029,7 +9029,14 @@
             <a:pPr lvl="0"/>
             <a:r>
               <a:rPr/>
-              <a:t>Three big names to remember:</a:t>
+              <a:t>After choosing a domain, read the matching notes and official docs.</a:t>
+            </a:r>
+          </a:p>
+          <a:p>
+            <a:pPr lvl="0"/>
+            <a:r>
+              <a:rPr/>
+              <a:t>A few big names you will see often:</a:t>
             </a:r>
           </a:p>
           <a:p>
@@ -9051,13 +9058,6 @@
             <a:r>
               <a:rPr/>
               <a:t>Sentence Transformers</a:t>
-            </a:r>
-          </a:p>
-          <a:p>
-            <a:pPr lvl="0"/>
-            <a:r>
-              <a:rPr/>
-              <a:t>After choosing a domain, read the matching notes and official docs.</a:t>
             </a:r>
           </a:p>
         </p:txBody>
@@ -9176,6 +9176,13 @@
             </a:r>
           </a:p>
           <a:p>
+            <a:pPr lvl="1"/>
+            <a:r>
+              <a:rPr/>
+              <a:t>Docker</a:t>
+            </a:r>
+          </a:p>
+          <a:p>
             <a:pPr lvl="0"/>
             <a:r>
               <a:rPr/>
@@ -9194,6 +9201,23 @@
             <a:r>
               <a:rPr/>
               <a:t>React gives more control, but also more complexity.</a:t>
+            </a:r>
+          </a:p>
+          <a:p>
+            <a:pPr lvl="0"/>
+            <a:r>
+              <a:rPr/>
+              <a:t>See </a:t>
+            </a:r>
+            <a:r>
+              <a:rPr>
+                <a:latin typeface="Cousine"/>
+              </a:rPr>
+              <a:t>04-generic-support-tooling.md</a:t>
+            </a:r>
+            <a:r>
+              <a:rPr/>
+              <a:t> in the repo for a short overview of these options.</a:t>
             </a:r>
           </a:p>
         </p:txBody>
@@ -9604,6 +9628,20 @@
             <a:pPr lvl="0"/>
             <a:r>
               <a:rPr/>
+              <a:t>choose an application domain</a:t>
+            </a:r>
+          </a:p>
+          <a:p>
+            <a:pPr lvl="0"/>
+            <a:r>
+              <a:rPr/>
+              <a:t>read the matching domain note</a:t>
+            </a:r>
+          </a:p>
+          <a:p>
+            <a:pPr lvl="0"/>
+            <a:r>
+              <a:rPr/>
               <a:t>choose a framework stack</a:t>
             </a:r>
           </a:p>
@@ -10217,6 +10255,23 @@
             <a:r>
               <a:rPr/>
               <a:t>3D / depth / geometry</a:t>
+            </a:r>
+          </a:p>
+          <a:p>
+            <a:pPr lvl="0"/>
+            <a:r>
+              <a:rPr/>
+              <a:t>Reinforcement learning and edge deployment also have dedicated notes in </a:t>
+            </a:r>
+            <a:r>
+              <a:rPr>
+                <a:latin typeface="Cousine"/>
+              </a:rPr>
+              <a:t>domains/</a:t>
+            </a:r>
+            <a:r>
+              <a:rPr/>
+              <a:t>.</a:t>
             </a:r>
           </a:p>
         </p:txBody>

</xml_diff>

<commit_message>
Allow multiple ways to choose project direction
</commit_message>
<xml_diff>
--- a/slides/deep-learning-project-domains.pptx
+++ b/slides/deep-learning-project-domains.pptx
@@ -9628,7 +9628,14 @@
             <a:pPr lvl="0"/>
             <a:r>
               <a:rPr/>
-              <a:t>choose an application domain</a:t>
+              <a:t>choose an application domain or framework stack</a:t>
+            </a:r>
+          </a:p>
+          <a:p>
+            <a:pPr lvl="0"/>
+            <a:r>
+              <a:rPr/>
+              <a:t>refine the other one</a:t>
             </a:r>
           </a:p>
           <a:p>
@@ -9636,13 +9643,6 @@
             <a:r>
               <a:rPr/>
               <a:t>read the matching domain note</a:t>
-            </a:r>
-          </a:p>
-          <a:p>
-            <a:pPr lvl="0"/>
-            <a:r>
-              <a:rPr/>
-              <a:t>choose a framework stack</a:t>
             </a:r>
           </a:p>
           <a:p>
@@ -10059,7 +10059,7 @@
             <a:pPr lvl="0"/>
             <a:r>
               <a:rPr/>
-              <a:t>Before choosing an application, it is often easier to choose a </a:t>
+              <a:t>For many projects, it helps to choose a </a:t>
             </a:r>
             <a:r>
               <a:rPr b="1"/>
@@ -10067,7 +10067,14 @@
             </a:r>
             <a:r>
               <a:rPr/>
-              <a:t>.</a:t>
+              <a:t> early.</a:t>
+            </a:r>
+          </a:p>
+          <a:p>
+            <a:pPr lvl="0"/>
+            <a:r>
+              <a:rPr/>
+              <a:t>Other students will start from a domain or tool they already find interesting.</a:t>
             </a:r>
           </a:p>
           <a:p>

</xml_diff>

<commit_message>
Simplify project next-step wording
</commit_message>
<xml_diff>
--- a/slides/deep-learning-project-domains.pptx
+++ b/slides/deep-learning-project-domains.pptx
@@ -9628,14 +9628,14 @@
             <a:pPr lvl="0"/>
             <a:r>
               <a:rPr/>
-              <a:t>choose an application domain or framework stack</a:t>
-            </a:r>
-          </a:p>
-          <a:p>
-            <a:pPr lvl="0"/>
-            <a:r>
-              <a:rPr/>
-              <a:t>then choose the matching domain or framework stack</a:t>
+              <a:t>choose a domain</a:t>
+            </a:r>
+          </a:p>
+          <a:p>
+            <a:pPr lvl="0"/>
+            <a:r>
+              <a:rPr/>
+              <a:t>find a matching framework stack</a:t>
             </a:r>
           </a:p>
           <a:p>

</xml_diff>